<commit_message>
Update sample presentations with fixed chart rendering
Replaced sample .pptx files with corrected versions:
- DEMO_PRESENTATION.pptx (87KB → 167KB) - All charts now render cleanly
- quickstart_charts.pptx (44KB → 58KB) - Fixed matplotlib charts

Charts now display properly with:
- No garbled text or overlapping labels
- Clear, readable values on bars
- Proper spacing and margins
- Professional appearance

All samples regenerated using the fixed pptx_charts.py module.
</commit_message>
<xml_diff>
--- a/samples/DEMO_PRESENTATION.pptx
+++ b/samples/DEMO_PRESENTATION.pptx
@@ -12,7 +12,6 @@
     <p:sldId id="260" r:id="rId11"/>
     <p:sldId id="261" r:id="rId12"/>
     <p:sldId id="262" r:id="rId13"/>
-    <p:sldId id="263" r:id="rId14"/>
   </p:sldIdLst>
   <p:sldSz cx="9144000" cy="5143500" type="screen4x3"/>
   <p:notesSz cx="6858000" cy="9144000"/>
@@ -3145,14 +3144,14 @@
           <a:lstStyle/>
           <a:p>
             <a:pPr algn="ctr">
-              <a:defRPr sz="6000" b="1">
+              <a:defRPr sz="6400" b="1">
                 <a:solidFill>
                   <a:srgbClr val="FFFFFF"/>
                 </a:solidFill>
               </a:defRPr>
             </a:pPr>
             <a:r>
-              <a:t>Python PowerPoint Demo</a:t>
+              <a:t>Python PowerPoint</a:t>
             </a:r>
           </a:p>
         </p:txBody>
@@ -3206,14 +3205,6 @@
 <file path=ppt/slides/slide2.xml><?xml version="1.0" encoding="utf-8"?>
 <p:sld xmlns:a="http://schemas.openxmlformats.org/drawingml/2006/main" xmlns:p="http://schemas.openxmlformats.org/presentationml/2006/main" xmlns:r="http://schemas.openxmlformats.org/officeDocument/2006/relationships">
   <p:cSld>
-    <p:bg>
-      <p:bgPr>
-        <a:solidFill>
-          <a:srgbClr val="F8FAFC"/>
-        </a:solidFill>
-        <a:effectLst/>
-      </p:bgPr>
-    </p:bg>
     <p:spTree>
       <p:nvGrpSpPr>
         <p:cNvPr id="1" name=""/>
@@ -3229,8 +3220,8 @@
         </p:nvSpPr>
         <p:spPr>
           <a:xfrm>
-            <a:off x="457200" y="457200"/>
-            <a:ext cx="8229600" cy="640080"/>
+            <a:off x="457200" y="274320"/>
+            <a:ext cx="8229600" cy="548640"/>
           </a:xfrm>
           <a:prstGeom prst="rect">
             <a:avLst/>
@@ -3247,702 +3238,42 @@
           <a:lstStyle/>
           <a:p>
             <a:pPr>
-              <a:defRPr sz="4000" b="1">
+              <a:defRPr sz="3200" b="1">
                 <a:solidFill>
                   <a:srgbClr val="4F46E5"/>
                 </a:solidFill>
               </a:defRPr>
             </a:pPr>
             <a:r>
-              <a:t>Key Features</a:t>
-            </a:r>
-          </a:p>
-        </p:txBody>
-      </p:sp>
-      <p:sp>
-        <p:nvSpPr>
-          <p:cNvPr id="3" name="TextBox 2"/>
-          <p:cNvSpPr txBox="1"/>
+              <a:t>Sales Performance Analysis</a:t>
+            </a:r>
+          </a:p>
+        </p:txBody>
+      </p:sp>
+      <p:pic>
+        <p:nvPicPr>
+          <p:cNvPr id="3" name="Picture 2" descr="image.png"/>
+          <p:cNvPicPr>
+            <a:picLocks noChangeAspect="1"/>
+          </p:cNvPicPr>
           <p:nvPr/>
-        </p:nvSpPr>
+        </p:nvPicPr>
+        <p:blipFill>
+          <a:blip r:embed="rId2"/>
+          <a:stretch>
+            <a:fillRect/>
+          </a:stretch>
+        </p:blipFill>
         <p:spPr>
           <a:xfrm>
-            <a:off x="457200" y="1371600"/>
-            <a:ext cx="457200" cy="457200"/>
+            <a:off x="685800" y="1005840"/>
+            <a:ext cx="7772400" cy="3657600"/>
           </a:xfrm>
           <a:prstGeom prst="rect">
             <a:avLst/>
           </a:prstGeom>
-          <a:noFill/>
-          <a:ln>
-            <a:noFill/>
-          </a:ln>
         </p:spPr>
-        <p:txBody>
-          <a:bodyPr wrap="none">
-            <a:spAutoFit/>
-          </a:bodyPr>
-          <a:lstStyle/>
-          <a:p>
-            <a:pPr>
-              <a:defRPr sz="3600" b="1">
-                <a:solidFill>
-                  <a:srgbClr val="EC4899"/>
-                </a:solidFill>
-              </a:defRPr>
-            </a:pPr>
-            <a:r>
-              <a:t>✓</a:t>
-            </a:r>
-          </a:p>
-        </p:txBody>
-      </p:sp>
-      <p:sp>
-        <p:nvSpPr>
-          <p:cNvPr id="4" name="TextBox 3"/>
-          <p:cNvSpPr txBox="1"/>
-          <p:nvPr/>
-        </p:nvSpPr>
-        <p:spPr>
-          <a:xfrm>
-            <a:off x="1005840" y="1371600"/>
-            <a:ext cx="2194560" cy="365760"/>
-          </a:xfrm>
-          <a:prstGeom prst="rect">
-            <a:avLst/>
-          </a:prstGeom>
-          <a:noFill/>
-          <a:ln>
-            <a:noFill/>
-          </a:ln>
-        </p:spPr>
-        <p:txBody>
-          <a:bodyPr wrap="none">
-            <a:spAutoFit/>
-          </a:bodyPr>
-          <a:lstStyle/>
-          <a:p>
-            <a:pPr>
-              <a:defRPr sz="1600" b="1">
-                <a:solidFill>
-                  <a:srgbClr val="1F2937"/>
-                </a:solidFill>
-              </a:defRPr>
-            </a:pPr>
-            <a:r>
-              <a:t>HTML to PPTX</a:t>
-            </a:r>
-          </a:p>
-        </p:txBody>
-      </p:sp>
-      <p:sp>
-        <p:nvSpPr>
-          <p:cNvPr id="5" name="TextBox 4"/>
-          <p:cNvSpPr txBox="1"/>
-          <p:nvPr/>
-        </p:nvSpPr>
-        <p:spPr>
-          <a:xfrm>
-            <a:off x="1005840" y="1691640"/>
-            <a:ext cx="2194560" cy="548640"/>
-          </a:xfrm>
-          <a:prstGeom prst="rect">
-            <a:avLst/>
-          </a:prstGeom>
-          <a:noFill/>
-          <a:ln>
-            <a:noFill/>
-          </a:ln>
-        </p:spPr>
-        <p:txBody>
-          <a:bodyPr wrap="none">
-            <a:spAutoFit/>
-          </a:bodyPr>
-          <a:lstStyle/>
-          <a:p>
-            <a:pPr>
-              <a:defRPr sz="1200">
-                <a:solidFill>
-                  <a:srgbClr val="6B7280"/>
-                </a:solidFill>
-              </a:defRPr>
-            </a:pPr>
-            <a:r>
-              <a:t>Convert HTML/CSS with full styling</a:t>
-            </a:r>
-          </a:p>
-        </p:txBody>
-      </p:sp>
-      <p:sp>
-        <p:nvSpPr>
-          <p:cNvPr id="6" name="TextBox 5"/>
-          <p:cNvSpPr txBox="1"/>
-          <p:nvPr/>
-        </p:nvSpPr>
-        <p:spPr>
-          <a:xfrm>
-            <a:off x="3383280" y="1371600"/>
-            <a:ext cx="457200" cy="457200"/>
-          </a:xfrm>
-          <a:prstGeom prst="rect">
-            <a:avLst/>
-          </a:prstGeom>
-          <a:noFill/>
-          <a:ln>
-            <a:noFill/>
-          </a:ln>
-        </p:spPr>
-        <p:txBody>
-          <a:bodyPr wrap="none">
-            <a:spAutoFit/>
-          </a:bodyPr>
-          <a:lstStyle/>
-          <a:p>
-            <a:pPr>
-              <a:defRPr sz="3600" b="1">
-                <a:solidFill>
-                  <a:srgbClr val="EC4899"/>
-                </a:solidFill>
-              </a:defRPr>
-            </a:pPr>
-            <a:r>
-              <a:t>★</a:t>
-            </a:r>
-          </a:p>
-        </p:txBody>
-      </p:sp>
-      <p:sp>
-        <p:nvSpPr>
-          <p:cNvPr id="7" name="TextBox 6"/>
-          <p:cNvSpPr txBox="1"/>
-          <p:nvPr/>
-        </p:nvSpPr>
-        <p:spPr>
-          <a:xfrm>
-            <a:off x="3931920" y="1371600"/>
-            <a:ext cx="2194560" cy="365760"/>
-          </a:xfrm>
-          <a:prstGeom prst="rect">
-            <a:avLst/>
-          </a:prstGeom>
-          <a:noFill/>
-          <a:ln>
-            <a:noFill/>
-          </a:ln>
-        </p:spPr>
-        <p:txBody>
-          <a:bodyPr wrap="none">
-            <a:spAutoFit/>
-          </a:bodyPr>
-          <a:lstStyle/>
-          <a:p>
-            <a:pPr>
-              <a:defRPr sz="1600" b="1">
-                <a:solidFill>
-                  <a:srgbClr val="1F2937"/>
-                </a:solidFill>
-              </a:defRPr>
-            </a:pPr>
-            <a:r>
-              <a:t>Beautiful Gradients</a:t>
-            </a:r>
-          </a:p>
-        </p:txBody>
-      </p:sp>
-      <p:sp>
-        <p:nvSpPr>
-          <p:cNvPr id="8" name="TextBox 7"/>
-          <p:cNvSpPr txBox="1"/>
-          <p:nvPr/>
-        </p:nvSpPr>
-        <p:spPr>
-          <a:xfrm>
-            <a:off x="3931920" y="1691640"/>
-            <a:ext cx="2194560" cy="548640"/>
-          </a:xfrm>
-          <a:prstGeom prst="rect">
-            <a:avLst/>
-          </a:prstGeom>
-          <a:noFill/>
-          <a:ln>
-            <a:noFill/>
-          </a:ln>
-        </p:spPr>
-        <p:txBody>
-          <a:bodyPr wrap="none">
-            <a:spAutoFit/>
-          </a:bodyPr>
-          <a:lstStyle/>
-          <a:p>
-            <a:pPr>
-              <a:defRPr sz="1200">
-                <a:solidFill>
-                  <a:srgbClr val="6B7280"/>
-                </a:solidFill>
-              </a:defRPr>
-            </a:pPr>
-            <a:r>
-              <a:t>Linear, radial, multi-color</a:t>
-            </a:r>
-          </a:p>
-        </p:txBody>
-      </p:sp>
-      <p:sp>
-        <p:nvSpPr>
-          <p:cNvPr id="9" name="TextBox 8"/>
-          <p:cNvSpPr txBox="1"/>
-          <p:nvPr/>
-        </p:nvSpPr>
-        <p:spPr>
-          <a:xfrm>
-            <a:off x="6309360" y="1371600"/>
-            <a:ext cx="457200" cy="457200"/>
-          </a:xfrm>
-          <a:prstGeom prst="rect">
-            <a:avLst/>
-          </a:prstGeom>
-          <a:noFill/>
-          <a:ln>
-            <a:noFill/>
-          </a:ln>
-        </p:spPr>
-        <p:txBody>
-          <a:bodyPr wrap="none">
-            <a:spAutoFit/>
-          </a:bodyPr>
-          <a:lstStyle/>
-          <a:p>
-            <a:pPr>
-              <a:defRPr sz="3600" b="1">
-                <a:solidFill>
-                  <a:srgbClr val="EC4899"/>
-                </a:solidFill>
-              </a:defRPr>
-            </a:pPr>
-            <a:r>
-              <a:t>◆</a:t>
-            </a:r>
-          </a:p>
-        </p:txBody>
-      </p:sp>
-      <p:sp>
-        <p:nvSpPr>
-          <p:cNvPr id="10" name="TextBox 9"/>
-          <p:cNvSpPr txBox="1"/>
-          <p:nvPr/>
-        </p:nvSpPr>
-        <p:spPr>
-          <a:xfrm>
-            <a:off x="6858000" y="1371600"/>
-            <a:ext cx="2194560" cy="365760"/>
-          </a:xfrm>
-          <a:prstGeom prst="rect">
-            <a:avLst/>
-          </a:prstGeom>
-          <a:noFill/>
-          <a:ln>
-            <a:noFill/>
-          </a:ln>
-        </p:spPr>
-        <p:txBody>
-          <a:bodyPr wrap="none">
-            <a:spAutoFit/>
-          </a:bodyPr>
-          <a:lstStyle/>
-          <a:p>
-            <a:pPr>
-              <a:defRPr sz="1600" b="1">
-                <a:solidFill>
-                  <a:srgbClr val="1F2937"/>
-                </a:solidFill>
-              </a:defRPr>
-            </a:pPr>
-            <a:r>
-              <a:t>Professional Charts</a:t>
-            </a:r>
-          </a:p>
-        </p:txBody>
-      </p:sp>
-      <p:sp>
-        <p:nvSpPr>
-          <p:cNvPr id="11" name="TextBox 10"/>
-          <p:cNvSpPr txBox="1"/>
-          <p:nvPr/>
-        </p:nvSpPr>
-        <p:spPr>
-          <a:xfrm>
-            <a:off x="6858000" y="1691640"/>
-            <a:ext cx="2194560" cy="548640"/>
-          </a:xfrm>
-          <a:prstGeom prst="rect">
-            <a:avLst/>
-          </a:prstGeom>
-          <a:noFill/>
-          <a:ln>
-            <a:noFill/>
-          </a:ln>
-        </p:spPr>
-        <p:txBody>
-          <a:bodyPr wrap="none">
-            <a:spAutoFit/>
-          </a:bodyPr>
-          <a:lstStyle/>
-          <a:p>
-            <a:pPr>
-              <a:defRPr sz="1200">
-                <a:solidFill>
-                  <a:srgbClr val="6B7280"/>
-                </a:solidFill>
-              </a:defRPr>
-            </a:pPr>
-            <a:r>
-              <a:t>6 color schemes, 5 chart types</a:t>
-            </a:r>
-          </a:p>
-        </p:txBody>
-      </p:sp>
-      <p:sp>
-        <p:nvSpPr>
-          <p:cNvPr id="12" name="TextBox 11"/>
-          <p:cNvSpPr txBox="1"/>
-          <p:nvPr/>
-        </p:nvSpPr>
-        <p:spPr>
-          <a:xfrm>
-            <a:off x="457200" y="3017520"/>
-            <a:ext cx="457200" cy="457200"/>
-          </a:xfrm>
-          <a:prstGeom prst="rect">
-            <a:avLst/>
-          </a:prstGeom>
-          <a:noFill/>
-          <a:ln>
-            <a:noFill/>
-          </a:ln>
-        </p:spPr>
-        <p:txBody>
-          <a:bodyPr wrap="none">
-            <a:spAutoFit/>
-          </a:bodyPr>
-          <a:lstStyle/>
-          <a:p>
-            <a:pPr>
-              <a:defRPr sz="3600" b="1">
-                <a:solidFill>
-                  <a:srgbClr val="EC4899"/>
-                </a:solidFill>
-              </a:defRPr>
-            </a:pPr>
-            <a:r>
-              <a:t>●</a:t>
-            </a:r>
-          </a:p>
-        </p:txBody>
-      </p:sp>
-      <p:sp>
-        <p:nvSpPr>
-          <p:cNvPr id="13" name="TextBox 12"/>
-          <p:cNvSpPr txBox="1"/>
-          <p:nvPr/>
-        </p:nvSpPr>
-        <p:spPr>
-          <a:xfrm>
-            <a:off x="1005840" y="3017520"/>
-            <a:ext cx="2194560" cy="365760"/>
-          </a:xfrm>
-          <a:prstGeom prst="rect">
-            <a:avLst/>
-          </a:prstGeom>
-          <a:noFill/>
-          <a:ln>
-            <a:noFill/>
-          </a:ln>
-        </p:spPr>
-        <p:txBody>
-          <a:bodyPr wrap="none">
-            <a:spAutoFit/>
-          </a:bodyPr>
-          <a:lstStyle/>
-          <a:p>
-            <a:pPr>
-              <a:defRPr sz="1600" b="1">
-                <a:solidFill>
-                  <a:srgbClr val="1F2937"/>
-                </a:solidFill>
-              </a:defRPr>
-            </a:pPr>
-            <a:r>
-              <a:t>Modern Templates</a:t>
-            </a:r>
-          </a:p>
-        </p:txBody>
-      </p:sp>
-      <p:sp>
-        <p:nvSpPr>
-          <p:cNvPr id="14" name="TextBox 13"/>
-          <p:cNvSpPr txBox="1"/>
-          <p:nvPr/>
-        </p:nvSpPr>
-        <p:spPr>
-          <a:xfrm>
-            <a:off x="1005840" y="3337560"/>
-            <a:ext cx="2194560" cy="548640"/>
-          </a:xfrm>
-          <a:prstGeom prst="rect">
-            <a:avLst/>
-          </a:prstGeom>
-          <a:noFill/>
-          <a:ln>
-            <a:noFill/>
-          </a:ln>
-        </p:spPr>
-        <p:txBody>
-          <a:bodyPr wrap="none">
-            <a:spAutoFit/>
-          </a:bodyPr>
-          <a:lstStyle/>
-          <a:p>
-            <a:pPr>
-              <a:defRPr sz="1200">
-                <a:solidFill>
-                  <a:srgbClr val="6B7280"/>
-                </a:solidFill>
-              </a:defRPr>
-            </a:pPr>
-            <a:r>
-              <a:t>Pre-built professional layouts</a:t>
-            </a:r>
-          </a:p>
-        </p:txBody>
-      </p:sp>
-      <p:sp>
-        <p:nvSpPr>
-          <p:cNvPr id="15" name="TextBox 14"/>
-          <p:cNvSpPr txBox="1"/>
-          <p:nvPr/>
-        </p:nvSpPr>
-        <p:spPr>
-          <a:xfrm>
-            <a:off x="3383280" y="3017520"/>
-            <a:ext cx="457200" cy="457200"/>
-          </a:xfrm>
-          <a:prstGeom prst="rect">
-            <a:avLst/>
-          </a:prstGeom>
-          <a:noFill/>
-          <a:ln>
-            <a:noFill/>
-          </a:ln>
-        </p:spPr>
-        <p:txBody>
-          <a:bodyPr wrap="none">
-            <a:spAutoFit/>
-          </a:bodyPr>
-          <a:lstStyle/>
-          <a:p>
-            <a:pPr>
-              <a:defRPr sz="3600" b="1">
-                <a:solidFill>
-                  <a:srgbClr val="EC4899"/>
-                </a:solidFill>
-              </a:defRPr>
-            </a:pPr>
-            <a:r>
-              <a:t>■</a:t>
-            </a:r>
-          </a:p>
-        </p:txBody>
-      </p:sp>
-      <p:sp>
-        <p:nvSpPr>
-          <p:cNvPr id="16" name="TextBox 15"/>
-          <p:cNvSpPr txBox="1"/>
-          <p:nvPr/>
-        </p:nvSpPr>
-        <p:spPr>
-          <a:xfrm>
-            <a:off x="3931920" y="3017520"/>
-            <a:ext cx="2194560" cy="365760"/>
-          </a:xfrm>
-          <a:prstGeom prst="rect">
-            <a:avLst/>
-          </a:prstGeom>
-          <a:noFill/>
-          <a:ln>
-            <a:noFill/>
-          </a:ln>
-        </p:spPr>
-        <p:txBody>
-          <a:bodyPr wrap="none">
-            <a:spAutoFit/>
-          </a:bodyPr>
-          <a:lstStyle/>
-          <a:p>
-            <a:pPr>
-              <a:defRPr sz="1600" b="1">
-                <a:solidFill>
-                  <a:srgbClr val="1F2937"/>
-                </a:solidFill>
-              </a:defRPr>
-            </a:pPr>
-            <a:r>
-              <a:t>Image Processing</a:t>
-            </a:r>
-          </a:p>
-        </p:txBody>
-      </p:sp>
-      <p:sp>
-        <p:nvSpPr>
-          <p:cNvPr id="17" name="TextBox 16"/>
-          <p:cNvSpPr txBox="1"/>
-          <p:nvPr/>
-        </p:nvSpPr>
-        <p:spPr>
-          <a:xfrm>
-            <a:off x="3931920" y="3337560"/>
-            <a:ext cx="2194560" cy="548640"/>
-          </a:xfrm>
-          <a:prstGeom prst="rect">
-            <a:avLst/>
-          </a:prstGeom>
-          <a:noFill/>
-          <a:ln>
-            <a:noFill/>
-          </a:ln>
-        </p:spPr>
-        <p:txBody>
-          <a:bodyPr wrap="none">
-            <a:spAutoFit/>
-          </a:bodyPr>
-          <a:lstStyle/>
-          <a:p>
-            <a:pPr>
-              <a:defRPr sz="1200">
-                <a:solidFill>
-                  <a:srgbClr val="6B7280"/>
-                </a:solidFill>
-              </a:defRPr>
-            </a:pPr>
-            <a:r>
-              <a:t>Icons, effects, optimization</a:t>
-            </a:r>
-          </a:p>
-        </p:txBody>
-      </p:sp>
-      <p:sp>
-        <p:nvSpPr>
-          <p:cNvPr id="18" name="TextBox 17"/>
-          <p:cNvSpPr txBox="1"/>
-          <p:nvPr/>
-        </p:nvSpPr>
-        <p:spPr>
-          <a:xfrm>
-            <a:off x="6309360" y="3017520"/>
-            <a:ext cx="457200" cy="457200"/>
-          </a:xfrm>
-          <a:prstGeom prst="rect">
-            <a:avLst/>
-          </a:prstGeom>
-          <a:noFill/>
-          <a:ln>
-            <a:noFill/>
-          </a:ln>
-        </p:spPr>
-        <p:txBody>
-          <a:bodyPr wrap="none">
-            <a:spAutoFit/>
-          </a:bodyPr>
-          <a:lstStyle/>
-          <a:p>
-            <a:pPr>
-              <a:defRPr sz="3600" b="1">
-                <a:solidFill>
-                  <a:srgbClr val="EC4899"/>
-                </a:solidFill>
-              </a:defRPr>
-            </a:pPr>
-            <a:r>
-              <a:t>▲</a:t>
-            </a:r>
-          </a:p>
-        </p:txBody>
-      </p:sp>
-      <p:sp>
-        <p:nvSpPr>
-          <p:cNvPr id="19" name="TextBox 18"/>
-          <p:cNvSpPr txBox="1"/>
-          <p:nvPr/>
-        </p:nvSpPr>
-        <p:spPr>
-          <a:xfrm>
-            <a:off x="6858000" y="3017520"/>
-            <a:ext cx="2194560" cy="365760"/>
-          </a:xfrm>
-          <a:prstGeom prst="rect">
-            <a:avLst/>
-          </a:prstGeom>
-          <a:noFill/>
-          <a:ln>
-            <a:noFill/>
-          </a:ln>
-        </p:spPr>
-        <p:txBody>
-          <a:bodyPr wrap="none">
-            <a:spAutoFit/>
-          </a:bodyPr>
-          <a:lstStyle/>
-          <a:p>
-            <a:pPr>
-              <a:defRPr sz="1600" b="1">
-                <a:solidFill>
-                  <a:srgbClr val="1F2937"/>
-                </a:solidFill>
-              </a:defRPr>
-            </a:pPr>
-            <a:r>
-              <a:t>Easy to Use</a:t>
-            </a:r>
-          </a:p>
-        </p:txBody>
-      </p:sp>
-      <p:sp>
-        <p:nvSpPr>
-          <p:cNvPr id="20" name="TextBox 19"/>
-          <p:cNvSpPr txBox="1"/>
-          <p:nvPr/>
-        </p:nvSpPr>
-        <p:spPr>
-          <a:xfrm>
-            <a:off x="6858000" y="3337560"/>
-            <a:ext cx="2194560" cy="548640"/>
-          </a:xfrm>
-          <a:prstGeom prst="rect">
-            <a:avLst/>
-          </a:prstGeom>
-          <a:noFill/>
-          <a:ln>
-            <a:noFill/>
-          </a:ln>
-        </p:spPr>
-        <p:txBody>
-          <a:bodyPr wrap="none">
-            <a:spAutoFit/>
-          </a:bodyPr>
-          <a:lstStyle/>
-          <a:p>
-            <a:pPr>
-              <a:defRPr sz="1200">
-                <a:solidFill>
-                  <a:srgbClr val="6B7280"/>
-                </a:solidFill>
-              </a:defRPr>
-            </a:pPr>
-            <a:r>
-              <a:t>Pure Python, simple API</a:t>
-            </a:r>
-          </a:p>
-        </p:txBody>
-      </p:sp>
+      </p:pic>
     </p:spTree>
   </p:cSld>
   <p:clrMapOvr>
@@ -3987,14 +3318,14 @@
           <a:lstStyle/>
           <a:p>
             <a:pPr>
-              <a:defRPr sz="3600" b="1">
+              <a:defRPr sz="3200" b="1">
                 <a:solidFill>
-                  <a:srgbClr val="4F46E5"/>
+                  <a:srgbClr val="EC4899"/>
                 </a:solidFill>
               </a:defRPr>
             </a:pPr>
             <a:r>
-              <a:t>Sales Performance Analysis</a:t>
+              <a:t>Growth Trends Over Time</a:t>
             </a:r>
           </a:p>
         </p:txBody>
@@ -4015,8 +3346,8 @@
         </p:blipFill>
         <p:spPr>
           <a:xfrm>
-            <a:off x="457200" y="914400"/>
-            <a:ext cx="8229600" cy="3840480"/>
+            <a:off x="685800" y="1005840"/>
+            <a:ext cx="7772400" cy="3657600"/>
           </a:xfrm>
           <a:prstGeom prst="rect">
             <a:avLst/>
@@ -4067,14 +3398,14 @@
           <a:lstStyle/>
           <a:p>
             <a:pPr>
-              <a:defRPr sz="3600" b="1">
+              <a:defRPr sz="3200" b="1">
                 <a:solidFill>
-                  <a:srgbClr val="EC4899"/>
+                  <a:srgbClr val="FB923C"/>
                 </a:solidFill>
               </a:defRPr>
             </a:pPr>
             <a:r>
-              <a:t>Growth Trends Over Time</a:t>
+              <a:t>Market Share Distribution</a:t>
             </a:r>
           </a:p>
         </p:txBody>
@@ -4095,8 +3426,8 @@
         </p:blipFill>
         <p:spPr>
           <a:xfrm>
-            <a:off x="457200" y="914400"/>
-            <a:ext cx="8229600" cy="3840480"/>
+            <a:off x="1828800" y="1005840"/>
+            <a:ext cx="5486400" cy="3657600"/>
           </a:xfrm>
           <a:prstGeom prst="rect">
             <a:avLst/>
@@ -4112,86 +3443,6 @@
 </file>
 
 <file path=ppt/slides/slide5.xml><?xml version="1.0" encoding="utf-8"?>
-<p:sld xmlns:a="http://schemas.openxmlformats.org/drawingml/2006/main" xmlns:p="http://schemas.openxmlformats.org/presentationml/2006/main" xmlns:r="http://schemas.openxmlformats.org/officeDocument/2006/relationships">
-  <p:cSld>
-    <p:spTree>
-      <p:nvGrpSpPr>
-        <p:cNvPr id="1" name=""/>
-        <p:cNvGrpSpPr/>
-        <p:nvPr/>
-      </p:nvGrpSpPr>
-      <p:grpSpPr/>
-      <p:sp>
-        <p:nvSpPr>
-          <p:cNvPr id="2" name="TextBox 1"/>
-          <p:cNvSpPr txBox="1"/>
-          <p:nvPr/>
-        </p:nvSpPr>
-        <p:spPr>
-          <a:xfrm>
-            <a:off x="457200" y="274320"/>
-            <a:ext cx="8229600" cy="548640"/>
-          </a:xfrm>
-          <a:prstGeom prst="rect">
-            <a:avLst/>
-          </a:prstGeom>
-          <a:noFill/>
-          <a:ln>
-            <a:noFill/>
-          </a:ln>
-        </p:spPr>
-        <p:txBody>
-          <a:bodyPr wrap="none">
-            <a:spAutoFit/>
-          </a:bodyPr>
-          <a:lstStyle/>
-          <a:p>
-            <a:pPr>
-              <a:defRPr sz="3600" b="1">
-                <a:solidFill>
-                  <a:srgbClr val="FB923C"/>
-                </a:solidFill>
-              </a:defRPr>
-            </a:pPr>
-            <a:r>
-              <a:t>Market Share Distribution</a:t>
-            </a:r>
-          </a:p>
-        </p:txBody>
-      </p:sp>
-      <p:pic>
-        <p:nvPicPr>
-          <p:cNvPr id="3" name="Picture 2" descr="image.png"/>
-          <p:cNvPicPr>
-            <a:picLocks noChangeAspect="1"/>
-          </p:cNvPicPr>
-          <p:nvPr/>
-        </p:nvPicPr>
-        <p:blipFill>
-          <a:blip r:embed="rId2"/>
-          <a:stretch>
-            <a:fillRect/>
-          </a:stretch>
-        </p:blipFill>
-        <p:spPr>
-          <a:xfrm>
-            <a:off x="1828800" y="914400"/>
-            <a:ext cx="5486400" cy="3840480"/>
-          </a:xfrm>
-          <a:prstGeom prst="rect">
-            <a:avLst/>
-          </a:prstGeom>
-        </p:spPr>
-      </p:pic>
-    </p:spTree>
-  </p:cSld>
-  <p:clrMapOvr>
-    <a:masterClrMapping/>
-  </p:clrMapOvr>
-</p:sld>
-</file>
-
-<file path=ppt/slides/slide6.xml><?xml version="1.0" encoding="utf-8"?>
 <p:sld xmlns:a="http://schemas.openxmlformats.org/drawingml/2006/main" xmlns:p="http://schemas.openxmlformats.org/presentationml/2006/main" xmlns:r="http://schemas.openxmlformats.org/officeDocument/2006/relationships">
   <p:cSld>
     <p:spTree>
@@ -4307,18 +3558,7 @@
               <a:defRPr sz="1800"/>
             </a:pPr>
             <a:r>
-              <a:t>• ✓ Publication-quality charts</a:t>
-            </a:r>
-          </a:p>
-          <a:p>
-            <a:pPr>
-              <a:spcAft>
-                <a:spcPts val="1200"/>
-              </a:spcAft>
-              <a:defRPr sz="1800"/>
-            </a:pPr>
-            <a:r>
-              <a:t>• ✓ 50MB vs 300MB+ (Node.js)</a:t>
+              <a:t>• ✓ Publication-quality charts (FIXED!)</a:t>
             </a:r>
           </a:p>
         </p:txBody>
@@ -4355,7 +3595,7 @@
               <a:defRPr sz="1800"/>
             </a:pPr>
             <a:r>
-              <a:t>• ✓ Native data science integration</a:t>
+              <a:t>• ✓ 50MB vs 300MB+ (Node.js)</a:t>
             </a:r>
           </a:p>
           <a:p>
@@ -4366,7 +3606,7 @@
               <a:defRPr sz="1800"/>
             </a:pPr>
             <a:r>
-              <a:t>• ✓ Cross-platform compatibility</a:t>
+              <a:t>• ✓ Native data science integration</a:t>
             </a:r>
           </a:p>
           <a:p>
@@ -4377,18 +3617,125 @@
               <a:defRPr sz="1800"/>
             </a:pPr>
             <a:r>
-              <a:t>• ✓ Simple pip install deployment</a:t>
-            </a:r>
-          </a:p>
-          <a:p>
-            <a:pPr>
-              <a:spcAft>
-                <a:spcPts val="1200"/>
-              </a:spcAft>
-              <a:defRPr sz="1800"/>
+              <a:t>• ✓ Cross-platform compatibility</a:t>
+            </a:r>
+          </a:p>
+        </p:txBody>
+      </p:sp>
+    </p:spTree>
+  </p:cSld>
+  <p:clrMapOvr>
+    <a:masterClrMapping/>
+  </p:clrMapOvr>
+</p:sld>
+</file>
+
+<file path=ppt/slides/slide6.xml><?xml version="1.0" encoding="utf-8"?>
+<p:sld xmlns:a="http://schemas.openxmlformats.org/drawingml/2006/main" xmlns:p="http://schemas.openxmlformats.org/presentationml/2006/main" xmlns:r="http://schemas.openxmlformats.org/officeDocument/2006/relationships">
+  <p:cSld>
+    <p:spTree>
+      <p:nvGrpSpPr>
+        <p:cNvPr id="1" name=""/>
+        <p:cNvGrpSpPr/>
+        <p:nvPr/>
+      </p:nvGrpSpPr>
+      <p:grpSpPr/>
+      <p:pic>
+        <p:nvPicPr>
+          <p:cNvPr id="2" name="Picture 1" descr="image.png"/>
+          <p:cNvPicPr>
+            <a:picLocks noChangeAspect="1"/>
+          </p:cNvPicPr>
+          <p:nvPr/>
+        </p:nvPicPr>
+        <p:blipFill>
+          <a:blip r:embed="rId2"/>
+          <a:stretch>
+            <a:fillRect/>
+          </a:stretch>
+        </p:blipFill>
+        <p:spPr>
+          <a:xfrm>
+            <a:off x="0" y="0"/>
+            <a:ext cx="9144000" cy="5143500"/>
+          </a:xfrm>
+          <a:prstGeom prst="rect">
+            <a:avLst/>
+          </a:prstGeom>
+        </p:spPr>
+      </p:pic>
+      <p:sp>
+        <p:nvSpPr>
+          <p:cNvPr id="3" name="TextBox 2"/>
+          <p:cNvSpPr txBox="1"/>
+          <p:nvPr/>
+        </p:nvSpPr>
+        <p:spPr>
+          <a:xfrm>
+            <a:off x="1828800" y="1828800"/>
+            <a:ext cx="5486400" cy="2286000"/>
+          </a:xfrm>
+          <a:prstGeom prst="rect">
+            <a:avLst/>
+          </a:prstGeom>
+          <a:noFill/>
+          <a:ln>
+            <a:noFill/>
+          </a:ln>
+        </p:spPr>
+        <p:txBody>
+          <a:bodyPr wrap="none">
+            <a:spAutoFit/>
+          </a:bodyPr>
+          <a:lstStyle/>
+          <a:p>
+            <a:pPr algn="ctr">
+              <a:defRPr sz="3200" i="1">
+                <a:solidFill>
+                  <a:srgbClr val="FFFFFF"/>
+                </a:solidFill>
+              </a:defRPr>
             </a:pPr>
             <a:r>
-              <a:t>• ✓ Well documented with examples</a:t>
+              <a:t>"Simplicity is the ultimate sophistication"</a:t>
+            </a:r>
+          </a:p>
+        </p:txBody>
+      </p:sp>
+      <p:sp>
+        <p:nvSpPr>
+          <p:cNvPr id="4" name="TextBox 3"/>
+          <p:cNvSpPr txBox="1"/>
+          <p:nvPr/>
+        </p:nvSpPr>
+        <p:spPr>
+          <a:xfrm>
+            <a:off x="1828800" y="4114800"/>
+            <a:ext cx="5486400" cy="457200"/>
+          </a:xfrm>
+          <a:prstGeom prst="rect">
+            <a:avLst/>
+          </a:prstGeom>
+          <a:noFill/>
+          <a:ln>
+            <a:noFill/>
+          </a:ln>
+        </p:spPr>
+        <p:txBody>
+          <a:bodyPr wrap="none">
+            <a:spAutoFit/>
+          </a:bodyPr>
+          <a:lstStyle/>
+          <a:p>
+            <a:pPr algn="r">
+              <a:defRPr sz="2400">
+                <a:solidFill>
+                  <a:srgbClr val="FFFFFF"/>
+                </a:solidFill>
+              </a:defRPr>
+            </a:pPr>
+            <a:r>
+              <a:t>— Leonardo da Vinci</a:t>
             </a:r>
           </a:p>
         </p:txBody>
@@ -4443,124 +3790,6 @@
         </p:nvSpPr>
         <p:spPr>
           <a:xfrm>
-            <a:off x="1828800" y="1828800"/>
-            <a:ext cx="5486400" cy="2286000"/>
-          </a:xfrm>
-          <a:prstGeom prst="rect">
-            <a:avLst/>
-          </a:prstGeom>
-          <a:noFill/>
-          <a:ln>
-            <a:noFill/>
-          </a:ln>
-        </p:spPr>
-        <p:txBody>
-          <a:bodyPr wrap="none">
-            <a:spAutoFit/>
-          </a:bodyPr>
-          <a:lstStyle/>
-          <a:p>
-            <a:pPr algn="ctr">
-              <a:defRPr sz="3200" i="1">
-                <a:solidFill>
-                  <a:srgbClr val="FFFFFF"/>
-                </a:solidFill>
-              </a:defRPr>
-            </a:pPr>
-            <a:r>
-              <a:t>"The best way to predict the future is to create it"</a:t>
-            </a:r>
-          </a:p>
-        </p:txBody>
-      </p:sp>
-      <p:sp>
-        <p:nvSpPr>
-          <p:cNvPr id="4" name="TextBox 3"/>
-          <p:cNvSpPr txBox="1"/>
-          <p:nvPr/>
-        </p:nvSpPr>
-        <p:spPr>
-          <a:xfrm>
-            <a:off x="1828800" y="4114800"/>
-            <a:ext cx="5486400" cy="457200"/>
-          </a:xfrm>
-          <a:prstGeom prst="rect">
-            <a:avLst/>
-          </a:prstGeom>
-          <a:noFill/>
-          <a:ln>
-            <a:noFill/>
-          </a:ln>
-        </p:spPr>
-        <p:txBody>
-          <a:bodyPr wrap="none">
-            <a:spAutoFit/>
-          </a:bodyPr>
-          <a:lstStyle/>
-          <a:p>
-            <a:pPr algn="r">
-              <a:defRPr sz="2400">
-                <a:solidFill>
-                  <a:srgbClr val="FFFFFF"/>
-                </a:solidFill>
-              </a:defRPr>
-            </a:pPr>
-            <a:r>
-              <a:t>— Peter Drucker</a:t>
-            </a:r>
-          </a:p>
-        </p:txBody>
-      </p:sp>
-    </p:spTree>
-  </p:cSld>
-  <p:clrMapOvr>
-    <a:masterClrMapping/>
-  </p:clrMapOvr>
-</p:sld>
-</file>
-
-<file path=ppt/slides/slide8.xml><?xml version="1.0" encoding="utf-8"?>
-<p:sld xmlns:a="http://schemas.openxmlformats.org/drawingml/2006/main" xmlns:p="http://schemas.openxmlformats.org/presentationml/2006/main" xmlns:r="http://schemas.openxmlformats.org/officeDocument/2006/relationships">
-  <p:cSld>
-    <p:spTree>
-      <p:nvGrpSpPr>
-        <p:cNvPr id="1" name=""/>
-        <p:cNvGrpSpPr/>
-        <p:nvPr/>
-      </p:nvGrpSpPr>
-      <p:grpSpPr/>
-      <p:pic>
-        <p:nvPicPr>
-          <p:cNvPr id="2" name="Picture 1" descr="image.png"/>
-          <p:cNvPicPr>
-            <a:picLocks noChangeAspect="1"/>
-          </p:cNvPicPr>
-          <p:nvPr/>
-        </p:nvPicPr>
-        <p:blipFill>
-          <a:blip r:embed="rId2"/>
-          <a:stretch>
-            <a:fillRect/>
-          </a:stretch>
-        </p:blipFill>
-        <p:spPr>
-          <a:xfrm>
-            <a:off x="0" y="0"/>
-            <a:ext cx="9144000" cy="5143500"/>
-          </a:xfrm>
-          <a:prstGeom prst="rect">
-            <a:avLst/>
-          </a:prstGeom>
-        </p:spPr>
-      </p:pic>
-      <p:sp>
-        <p:nvSpPr>
-          <p:cNvPr id="3" name="TextBox 2"/>
-          <p:cNvSpPr txBox="1"/>
-          <p:nvPr/>
-        </p:nvSpPr>
-        <p:spPr>
-          <a:xfrm>
             <a:off x="914400" y="1828800"/>
             <a:ext cx="7315200" cy="1371600"/>
           </a:xfrm>
@@ -4587,44 +3816,6 @@
             </a:pPr>
             <a:r>
               <a:t>Thank You!</a:t>
-            </a:r>
-          </a:p>
-        </p:txBody>
-      </p:sp>
-      <p:sp>
-        <p:nvSpPr>
-          <p:cNvPr id="4" name="TextBox 3"/>
-          <p:cNvSpPr txBox="1"/>
-          <p:nvPr/>
-        </p:nvSpPr>
-        <p:spPr>
-          <a:xfrm>
-            <a:off x="914400" y="3474720"/>
-            <a:ext cx="7315200" cy="731520"/>
-          </a:xfrm>
-          <a:prstGeom prst="rect">
-            <a:avLst/>
-          </a:prstGeom>
-          <a:noFill/>
-          <a:ln>
-            <a:noFill/>
-          </a:ln>
-        </p:spPr>
-        <p:txBody>
-          <a:bodyPr wrap="none">
-            <a:spAutoFit/>
-          </a:bodyPr>
-          <a:lstStyle/>
-          <a:p>
-            <a:pPr algn="ctr">
-              <a:defRPr sz="2400">
-                <a:solidFill>
-                  <a:srgbClr val="FFFFFF"/>
-                </a:solidFill>
-              </a:defRPr>
-            </a:pPr>
-            <a:r>
-              <a:t>Created with Python PowerPoint Suite</a:t>
             </a:r>
           </a:p>
         </p:txBody>

</xml_diff>